<commit_message>
Final slides: neutral wording for the stopped LLM run, add the same-model note
</commit_message>
<xml_diff>
--- a/docs/final/oguz-slaytlar.pptx
+++ b/docs/final/oguz-slaytlar.pptx
@@ -644,7 +644,7 @@
           <a:lstStyle/>
           <a:p>
             <a:r>
-              <a:t>Aynı operasyonları bir LLM'e çevirttik, kodunu bizim eşdeğerlik testlerimizle çalıştırdık. 15 çıktının hepsi derlendi ve 10 testin 10'unu geçti; bizim kodumuz da 10/10. Testlerin kendisi 10 tane olduğu için ikisini ayıramadı; ek olarak belgedeki 16 davranışı ölçüm dışı yokladık, onda da hata çıkmadı. Plan 18 operasyondu; API kredisi bitince beş operasyon (15 çağrı) ölçüme kaldı, bu yüzden sonuç genellenemez. Kaynak: tests/results/llm-comparison.md.</a:t>
+              <a:t>Aynı operasyonları bir LLM'e çevirttik, kodunu bizim eşdeğerlik testlerimizle çalıştırdık. 15 çıktının hepsi derlendi ve 10 testin 10'unu geçti; bizim kodumuz da 10/10. Testlerin kendisi 10 tane olduğu için ikisini ayıramadı; ek olarak belgedeki 16 davranışı ölçüm dışı yokladık, onda da hata çıkmadı. Plan 18 operasyondu; çalıştırma ekip kararıyla 16 çağrıda durduruldu ve beş operasyon (15 çağrı) ölçüme kaldı, bu yüzden sonuç genellenemez. Bizim kodumuz da Claude Code yardımıyla yazıldı; karşılaştırma insan ile yapay zekâ arasında değil, adım adım yazılan kod ile tek seferde çevrilen kod arasındadır. Kaynak: tests/results/llm-comparison.md.</a:t>
             </a:r>
           </a:p>
         </p:txBody>
@@ -5534,7 +5534,7 @@
               </a:defRPr>
             </a:pPr>
             <a:r>
-              <a:t>Seçim rastgele değil (kredi bitti).</a:t>
+              <a:t>Seçim rastgele değil: çalıştırma sırasında ilk gelen 5 operasyon.</a:t>
             </a:r>
           </a:p>
         </p:txBody>

</xml_diff>